<commit_message>
kicsit igazgattam még a diákon
</commit_message>
<xml_diff>
--- a/docs/print-shop-presentation_final.pptx
+++ b/docs/print-shop-presentation_final.pptx
@@ -11641,7 +11641,7 @@
         </p:nvSpPr>
         <p:spPr>
           <a:xfrm>
-            <a:off x="320040" y="2084832"/>
+            <a:off x="320040" y="1917627"/>
             <a:ext cx="2560320" cy="457200"/>
           </a:xfrm>
           <a:prstGeom prst="rect">
@@ -11680,7 +11680,7 @@
         </p:nvSpPr>
         <p:spPr>
           <a:xfrm>
-            <a:off x="320040" y="2615184"/>
+            <a:off x="301752" y="2278161"/>
             <a:ext cx="2560320" cy="457200"/>
           </a:xfrm>
           <a:prstGeom prst="rect">
@@ -11719,7 +11719,7 @@
         </p:nvSpPr>
         <p:spPr>
           <a:xfrm>
-            <a:off x="320040" y="2999232"/>
+            <a:off x="301752" y="2685725"/>
             <a:ext cx="2560320" cy="457200"/>
           </a:xfrm>
           <a:prstGeom prst="rect">
@@ -11758,7 +11758,7 @@
         </p:nvSpPr>
         <p:spPr>
           <a:xfrm>
-            <a:off x="320040" y="3675888"/>
+            <a:off x="301752" y="3416437"/>
             <a:ext cx="2560320" cy="457200"/>
           </a:xfrm>
           <a:prstGeom prst="rect">
@@ -11797,7 +11797,7 @@
         </p:nvSpPr>
         <p:spPr>
           <a:xfrm>
-            <a:off x="301752" y="4133088"/>
+            <a:off x="301752" y="3860072"/>
             <a:ext cx="2560320" cy="457200"/>
           </a:xfrm>
           <a:prstGeom prst="rect">
@@ -11996,7 +11996,7 @@
         </p:nvSpPr>
         <p:spPr>
           <a:xfrm>
-            <a:off x="3264408" y="2084832"/>
+            <a:off x="3246120" y="1903329"/>
             <a:ext cx="2560320" cy="457200"/>
           </a:xfrm>
           <a:prstGeom prst="rect">
@@ -12035,7 +12035,7 @@
         </p:nvSpPr>
         <p:spPr>
           <a:xfrm>
-            <a:off x="3264408" y="2615184"/>
+            <a:off x="3227832" y="2314391"/>
             <a:ext cx="2560320" cy="457200"/>
           </a:xfrm>
           <a:prstGeom prst="rect">
@@ -12074,7 +12074,7 @@
         </p:nvSpPr>
         <p:spPr>
           <a:xfrm>
-            <a:off x="283464" y="4498848"/>
+            <a:off x="301752" y="4230250"/>
             <a:ext cx="2560320" cy="457200"/>
           </a:xfrm>
           <a:prstGeom prst="rect">
@@ -12113,7 +12113,7 @@
         </p:nvSpPr>
         <p:spPr>
           <a:xfrm>
-            <a:off x="320040" y="3361073"/>
+            <a:off x="301752" y="3046259"/>
             <a:ext cx="2560320" cy="457200"/>
           </a:xfrm>
           <a:prstGeom prst="rect">
@@ -12152,7 +12152,7 @@
         </p:nvSpPr>
         <p:spPr>
           <a:xfrm>
-            <a:off x="3264408" y="4206240"/>
+            <a:off x="3264408" y="4078470"/>
             <a:ext cx="2560320" cy="457200"/>
           </a:xfrm>
           <a:prstGeom prst="rect">
@@ -12351,7 +12351,7 @@
         </p:nvSpPr>
         <p:spPr>
           <a:xfrm>
-            <a:off x="6208776" y="2084832"/>
+            <a:off x="6208776" y="1929384"/>
             <a:ext cx="2560320" cy="457200"/>
           </a:xfrm>
           <a:prstGeom prst="rect">
@@ -12407,7 +12407,7 @@
         </p:nvSpPr>
         <p:spPr>
           <a:xfrm>
-            <a:off x="3172968" y="3187238"/>
+            <a:off x="3172968" y="2859361"/>
             <a:ext cx="2462349" cy="415498"/>
           </a:xfrm>
           <a:prstGeom prst="rect">
@@ -12464,7 +12464,7 @@
         </p:nvSpPr>
         <p:spPr>
           <a:xfrm>
-            <a:off x="3172968" y="3578230"/>
+            <a:off x="3172968" y="3249543"/>
             <a:ext cx="2743200" cy="253916"/>
           </a:xfrm>
           <a:prstGeom prst="rect">
@@ -12606,7 +12606,7 @@
         </p:nvSpPr>
         <p:spPr>
           <a:xfrm>
-            <a:off x="3264408" y="3971109"/>
+            <a:off x="3123982" y="3733114"/>
             <a:ext cx="2560320" cy="253916"/>
           </a:xfrm>
           <a:prstGeom prst="rect">

</xml_diff>